<commit_message>
Tailor deck for technical audience
</commit_message>
<xml_diff>
--- a/slides/Break-My-API-HMSep26.pptx
+++ b/slides/Break-My-API-HMSep26.pptx
@@ -2376,7 +2376,7 @@
           <a:p>
             <a:r>
               <a:rPr lang="en-US" dirty="0"/>
-              <a:t>Quick theory for anyone new. An API is a menu of requests a program accepts. The status code is its one-word verdict. Most of today's tests just ask: when I send something wrong, do I get a 4xx?</a:t>
+              <a:t>Quick look at the setup. FastAPI app with 10 planted bugs over SQLite. A local model through Ollama writes the tests as JSON. A small httpx runner executes them and compares status codes. Two demo scripts cover what one-request tests can't: concurrency and chained business logic. Everything is offline and resets before each test, so results are repeatable.</a:t>
             </a:r>
             <a:endParaRPr lang="en-US" dirty="0"/>
           </a:p>
@@ -2399,7 +2399,7 @@
           <a:p>
             <a:fld id="{F7021451-1387-4CA6-816F-3879F97B5CBC}" type="slidenum">
               <a:rPr lang="en-US"/>
-              <a:t>4</a:t>
+              <a:t>1</a:t>
             </a:fld>
             <a:endParaRPr lang="en-US"/>
           </a:p>
@@ -6258,7 +6258,7 @@
                 <a:ea typeface="Courier New" pitchFamily="34" charset="-122"/>
                 <a:cs typeface="Courier New" pitchFamily="34" charset="-120"/>
               </a:rPr>
-              <a:t>THEORY · TRIAGE</a:t>
+              <a:t>TRIAGE</a:t>
             </a:r>
             <a:endParaRPr lang="en-US" sz="975" dirty="0"/>
           </a:p>
@@ -13173,7 +13173,7 @@
                 <a:ea typeface="Arial" pitchFamily="34" charset="-122"/>
                 <a:cs typeface="Arial" pitchFamily="34" charset="-120"/>
               </a:rPr>
-              <a:t>Happy path:</a:t>
+              <a:t>Tests encode my assumptions:</a:t>
             </a:r>
             <a:pPr indent="0" marL="0">
               <a:spcAft>
@@ -13190,7 +13190,7 @@
                 <a:ea typeface="Arial" pitchFamily="34" charset="-122"/>
                 <a:cs typeface="Arial" pitchFamily="34" charset="-120"/>
               </a:rPr>
-              <a:t> we test the one normal way the feature is used.</a:t>
+              <a:t> quantity: int silently means "positive" in my head. Never written down, so never tested.</a:t>
             </a:r>
             <a:endParaRPr lang="en-US" sz="1425" dirty="0"/>
           </a:p>
@@ -13211,7 +13211,7 @@
                 <a:ea typeface="Arial" pitchFamily="34" charset="-122"/>
                 <a:cs typeface="Arial" pitchFamily="34" charset="-120"/>
               </a:rPr>
-              <a:t>Curse of knowledge:</a:t>
+              <a:t>Types are not values:</a:t>
             </a:r>
             <a:pPr indent="0" marL="0">
               <a:spcAft>
@@ -13228,7 +13228,7 @@
                 <a:ea typeface="Arial" pitchFamily="34" charset="-122"/>
                 <a:cs typeface="Arial" pitchFamily="34" charset="-120"/>
               </a:rPr>
-              <a:t> the author shares every assumption the code makes, so those assumptions never get tested.</a:t>
+              <a:t> Pydantic rejects "abc" but happily accepts -5.</a:t>
             </a:r>
             <a:endParaRPr lang="en-US" sz="1425" dirty="0"/>
           </a:p>
@@ -13249,7 +13249,7 @@
                 <a:ea typeface="Arial" pitchFamily="34" charset="-122"/>
                 <a:cs typeface="Arial" pitchFamily="34" charset="-120"/>
               </a:rPr>
-              <a:t>Real traffic is different:</a:t>
+              <a:t>Production is not the happy path:</a:t>
             </a:r>
             <a:pPr indent="0" marL="0">
               <a:spcAft>
@@ -13266,7 +13266,7 @@
                 <a:ea typeface="Arial" pitchFamily="34" charset="-122"/>
                 <a:cs typeface="Arial" pitchFamily="34" charset="-120"/>
               </a:rPr>
-              <a:t> confused users, double-clicks, retries, attackers, 100 people at once.</a:t>
+              <a:t> retries, replays, forged tokens, concurrent writes.</a:t>
             </a:r>
             <a:endParaRPr lang="en-US" sz="1425" dirty="0"/>
           </a:p>
@@ -13457,7 +13457,7 @@
 
 <file path=ppt/slides/slide4.xml><?xml version="1.0" encoding="utf-8"?>
 <p:sld xmlns:a="http://schemas.openxmlformats.org/drawingml/2006/main" xmlns:r="http://schemas.openxmlformats.org/officeDocument/2006/relationships" xmlns:p="http://schemas.openxmlformats.org/presentationml/2006/main">
-  <p:cSld name="Slide 4">
+  <p:cSld name="Slide 1">
     <p:bg>
       <p:bgPr>
         <a:solidFill>
@@ -13481,7 +13481,7 @@
       </p:grpSpPr>
       <p:pic>
         <p:nvPicPr>
-          <p:cNvPr id="3" name="Image 0" descr="bg/bg-04.png">    </p:cNvPr>
+          <p:cNvPr id="2" name="Image 0" descr="bg4.png">    </p:cNvPr>
           <p:cNvPicPr>
             <a:picLocks noChangeAspect="1"/>
           </p:cNvPicPr>
@@ -13505,7 +13505,7 @@
       </p:pic>
       <p:sp>
         <p:nvSpPr>
-          <p:cNvPr id="4" name="Text 0"/>
+          <p:cNvPr id="3" name="Text 0"/>
           <p:cNvSpPr txBox="1"/>
           <p:nvPr/>
         </p:nvSpPr>
@@ -13544,14 +13544,14 @@
       </p:sp>
       <p:sp>
         <p:nvSpPr>
-          <p:cNvPr id="5" name="Text 1"/>
-          <p:cNvSpPr txBox="1"/>
-          <p:nvPr/>
-        </p:nvSpPr>
-        <p:spPr>
-          <a:xfrm>
-            <a:off x="411480" y="308610"/>
-            <a:ext cx="6172200" cy="240030"/>
+          <p:cNvPr id="4" name="Text 1"/>
+          <p:cNvSpPr txBox="1"/>
+          <p:nvPr/>
+        </p:nvSpPr>
+        <p:spPr>
+          <a:xfrm>
+            <a:off x="411480" y="309067"/>
+            <a:ext cx="6172200" cy="240487"/>
           </a:xfrm>
           <a:prstGeom prst="rect">
             <a:avLst/>
@@ -13575,7 +13575,7 @@
                 <a:ea typeface="Courier New" pitchFamily="34" charset="-122"/>
                 <a:cs typeface="Courier New" pitchFamily="34" charset="-120"/>
               </a:rPr>
-              <a:t>THEORY · 1 MINUTE</a:t>
+              <a:t>THE SETUP</a:t>
             </a:r>
             <a:endParaRPr lang="en-US" sz="975" dirty="0"/>
           </a:p>
@@ -13583,14 +13583,14 @@
       </p:sp>
       <p:sp>
         <p:nvSpPr>
-          <p:cNvPr id="6" name="Text 2"/>
+          <p:cNvPr id="5" name="Text 2"/>
           <p:cNvSpPr txBox="1"/>
           <p:nvPr/>
         </p:nvSpPr>
         <p:spPr>
           <a:xfrm>
             <a:off x="411480" y="548640"/>
-            <a:ext cx="8320857" cy="582930"/>
+            <a:ext cx="8321040" cy="582473"/>
           </a:xfrm>
           <a:prstGeom prst="rect">
             <a:avLst/>
@@ -13614,7 +13614,7 @@
                 <a:ea typeface="Arial" pitchFamily="34" charset="-122"/>
                 <a:cs typeface="Arial" pitchFamily="34" charset="-120"/>
               </a:rPr>
-              <a:t>What an API is, and how it answers</a:t>
+              <a:t>Stack: FastAPI, SQLite and a local LLM</a:t>
             </a:r>
             <a:endParaRPr lang="en-US" sz="2400" dirty="0"/>
           </a:p>
@@ -13622,13 +13622,13 @@
       </p:sp>
       <p:sp>
         <p:nvSpPr>
-          <p:cNvPr id="7" name="Text 3"/>
-          <p:cNvSpPr txBox="1"/>
-          <p:nvPr/>
-        </p:nvSpPr>
-        <p:spPr>
-          <a:xfrm>
-            <a:off x="8320857" y="4766310"/>
+          <p:cNvPr id="6" name="Text 3"/>
+          <p:cNvSpPr txBox="1"/>
+          <p:nvPr/>
+        </p:nvSpPr>
+        <p:spPr>
+          <a:xfrm>
+            <a:off x="8321040" y="4766767"/>
             <a:ext cx="411480" cy="205740"/>
           </a:xfrm>
           <a:prstGeom prst="rect">
@@ -13661,34 +13661,405 @@
       </p:sp>
       <p:sp>
         <p:nvSpPr>
-          <p:cNvPr id="8" name="Text 4"/>
+          <p:cNvPr id="7" name="Text 4"/>
           <p:cNvSpPr txBox="1"/>
           <p:nvPr/>
         </p:nvSpPr>
         <p:spPr>
           <a:xfrm>
             <a:off x="411480" y="1303020"/>
-            <a:ext cx="8320857" cy="1440180"/>
-          </a:xfrm>
-          <a:prstGeom prst="rect">
-            <a:avLst/>
-          </a:prstGeom>
-          <a:noFill/>
-          <a:ln/>
-        </p:spPr>
-        <p:txBody>
-          <a:bodyPr wrap="square" lIns="0" tIns="0" rIns="0" bIns="0" rtlCol="0" anchor="t"/>
-          <a:lstStyle/>
-          <a:p>
-            <a:pPr marL="215900" indent="-215900">
+            <a:ext cx="5120640" cy="2697480"/>
+          </a:xfrm>
+          <a:prstGeom prst="rect">
+            <a:avLst/>
+          </a:prstGeom>
+          <a:noFill/>
+          <a:ln/>
+        </p:spPr>
+        <p:txBody>
+          <a:bodyPr wrap="square" lIns="127000" tIns="127000" rIns="127000" bIns="127000" rtlCol="0" anchor="ctr"/>
+          <a:lstStyle/>
+          <a:p>
+            <a:pPr indent="0" marL="0">
               <a:spcAft>
-                <a:spcPts val="750"/>
+                <a:spcPts val="900"/>
               </a:spcAft>
-              <a:buSzPct val="100000"/>
-              <a:buChar char="•"/>
-            </a:pPr>
-            <a:r>
-              <a:rPr lang="en-US" sz="1425" b="1" dirty="0">
+              <a:buNone/>
+            </a:pPr>
+            <a:r>
+              <a:rPr lang="en-US" sz="1050" dirty="0">
+                <a:solidFill>
+                  <a:srgbClr val="FFCB6B"/>
+                </a:solidFill>
+                <a:latin typeface="Courier New" pitchFamily="34" charset="0"/>
+                <a:ea typeface="Courier New" pitchFamily="34" charset="-122"/>
+                <a:cs typeface="Courier New" pitchFamily="34" charset="-120"/>
+              </a:rPr>
+              <a:t>app/main.py      </a:t>
+            </a:r>
+            <a:pPr indent="0" marL="0">
+              <a:spcAft>
+                <a:spcPts val="900"/>
+              </a:spcAft>
+              <a:buNone/>
+            </a:pPr>
+            <a:r>
+              <a:rPr lang="en-US" sz="1050" dirty="0">
+                <a:solidFill>
+                  <a:srgbClr val="E6E8F2"/>
+                </a:solidFill>
+                <a:latin typeface="Courier New" pitchFamily="34" charset="0"/>
+                <a:ea typeface="Courier New" pitchFamily="34" charset="-122"/>
+                <a:cs typeface="Courier New" pitchFamily="34" charset="-120"/>
+              </a:rPr>
+              <a:t>FastAPI · 6 endpoints · 10 bugs</a:t>
+            </a:r>
+            <a:endParaRPr lang="en-US" sz="1050" dirty="0"/>
+          </a:p>
+          <a:p>
+            <a:pPr indent="0" marL="0">
+              <a:spcAft>
+                <a:spcPts val="900"/>
+              </a:spcAft>
+              <a:buNone/>
+            </a:pPr>
+            <a:r>
+              <a:rPr lang="en-US" sz="1050" dirty="0">
+                <a:solidFill>
+                  <a:srgbClr val="FFCB6B"/>
+                </a:solidFill>
+                <a:latin typeface="Courier New" pitchFamily="34" charset="0"/>
+                <a:ea typeface="Courier New" pitchFamily="34" charset="-122"/>
+                <a:cs typeface="Courier New" pitchFamily="34" charset="-120"/>
+              </a:rPr>
+              <a:t>app/db.py        </a:t>
+            </a:r>
+            <a:pPr indent="0" marL="0">
+              <a:spcAft>
+                <a:spcPts val="900"/>
+              </a:spcAft>
+              <a:buNone/>
+            </a:pPr>
+            <a:r>
+              <a:rPr lang="en-US" sz="1050" dirty="0">
+                <a:solidFill>
+                  <a:srgbClr val="E6E8F2"/>
+                </a:solidFill>
+                <a:latin typeface="Courier New" pitchFamily="34" charset="0"/>
+                <a:ea typeface="Courier New" pitchFamily="34" charset="-122"/>
+                <a:cs typeface="Courier New" pitchFamily="34" charset="-120"/>
+              </a:rPr>
+              <a:t>SQLite · reset before each test</a:t>
+            </a:r>
+            <a:endParaRPr lang="en-US" sz="1050" dirty="0"/>
+          </a:p>
+          <a:p>
+            <a:pPr indent="0" marL="0">
+              <a:spcAft>
+                <a:spcPts val="900"/>
+              </a:spcAft>
+              <a:buNone/>
+            </a:pPr>
+            <a:r>
+              <a:rPr lang="en-US" sz="1050" dirty="0">
+                <a:solidFill>
+                  <a:srgbClr val="FFCB6B"/>
+                </a:solidFill>
+                <a:latin typeface="Courier New" pitchFamily="34" charset="0"/>
+                <a:ea typeface="Courier New" pitchFamily="34" charset="-122"/>
+                <a:cs typeface="Courier New" pitchFamily="34" charset="-120"/>
+              </a:rPr>
+              <a:t>ai/generate.py   </a:t>
+            </a:r>
+            <a:pPr indent="0" marL="0">
+              <a:spcAft>
+                <a:spcPts val="900"/>
+              </a:spcAft>
+              <a:buNone/>
+            </a:pPr>
+            <a:r>
+              <a:rPr lang="en-US" sz="1050" dirty="0">
+                <a:solidFill>
+                  <a:srgbClr val="E6E8F2"/>
+                </a:solidFill>
+                <a:latin typeface="Courier New" pitchFamily="34" charset="0"/>
+                <a:ea typeface="Courier New" pitchFamily="34" charset="-122"/>
+                <a:cs typeface="Courier New" pitchFamily="34" charset="-120"/>
+              </a:rPr>
+              <a:t>Ollama · qwen2.5-coder:7b · JSON</a:t>
+            </a:r>
+            <a:endParaRPr lang="en-US" sz="1050" dirty="0"/>
+          </a:p>
+          <a:p>
+            <a:pPr indent="0" marL="0">
+              <a:spcAft>
+                <a:spcPts val="900"/>
+              </a:spcAft>
+              <a:buNone/>
+            </a:pPr>
+            <a:r>
+              <a:rPr lang="en-US" sz="1050" dirty="0">
+                <a:solidFill>
+                  <a:srgbClr val="FFCB6B"/>
+                </a:solidFill>
+                <a:latin typeface="Courier New" pitchFamily="34" charset="0"/>
+                <a:ea typeface="Courier New" pitchFamily="34" charset="-122"/>
+                <a:cs typeface="Courier New" pitchFamily="34" charset="-120"/>
+              </a:rPr>
+              <a:t>tests/runner.py  </a:t>
+            </a:r>
+            <a:pPr indent="0" marL="0">
+              <a:spcAft>
+                <a:spcPts val="900"/>
+              </a:spcAft>
+              <a:buNone/>
+            </a:pPr>
+            <a:r>
+              <a:rPr lang="en-US" sz="1050" dirty="0">
+                <a:solidFill>
+                  <a:srgbClr val="E6E8F2"/>
+                </a:solidFill>
+                <a:latin typeface="Courier New" pitchFamily="34" charset="0"/>
+                <a:ea typeface="Courier New" pitchFamily="34" charset="-122"/>
+                <a:cs typeface="Courier New" pitchFamily="34" charset="-120"/>
+              </a:rPr>
+              <a:t> httpx · status-code oracle</a:t>
+            </a:r>
+            <a:endParaRPr lang="en-US" sz="1050" dirty="0"/>
+          </a:p>
+          <a:p>
+            <a:pPr indent="0" marL="0">
+              <a:spcAft>
+                <a:spcPts val="900"/>
+              </a:spcAft>
+              <a:buNone/>
+            </a:pPr>
+            <a:r>
+              <a:rPr lang="en-US" sz="1050" dirty="0">
+                <a:solidFill>
+                  <a:srgbClr val="FFCB6B"/>
+                </a:solidFill>
+                <a:latin typeface="Courier New" pitchFamily="34" charset="0"/>
+                <a:ea typeface="Courier New" pitchFamily="34" charset="-122"/>
+                <a:cs typeface="Courier New" pitchFamily="34" charset="-120"/>
+              </a:rPr>
+              <a:t>demo/*.py        </a:t>
+            </a:r>
+            <a:pPr indent="0" marL="0">
+              <a:spcAft>
+                <a:spcPts val="900"/>
+              </a:spcAft>
+              <a:buNone/>
+            </a:pPr>
+            <a:r>
+              <a:rPr lang="en-US" sz="1050" dirty="0">
+                <a:solidFill>
+                  <a:srgbClr val="E6E8F2"/>
+                </a:solidFill>
+                <a:latin typeface="Courier New" pitchFamily="34" charset="0"/>
+                <a:ea typeface="Courier New" pitchFamily="34" charset="-122"/>
+                <a:cs typeface="Courier New" pitchFamily="34" charset="-120"/>
+              </a:rPr>
+              <a:t>20-thread race · money loop</a:t>
+            </a:r>
+            <a:endParaRPr lang="en-US" sz="1050" dirty="0"/>
+          </a:p>
+        </p:txBody>
+      </p:sp>
+      <p:sp>
+        <p:nvSpPr>
+          <p:cNvPr id="8" name="Text 5"/>
+          <p:cNvSpPr txBox="1"/>
+          <p:nvPr/>
+        </p:nvSpPr>
+        <p:spPr>
+          <a:xfrm>
+            <a:off x="5715000" y="1303020"/>
+            <a:ext cx="3017520" cy="822960"/>
+          </a:xfrm>
+          <a:prstGeom prst="rect">
+            <a:avLst/>
+          </a:prstGeom>
+          <a:noFill/>
+          <a:ln/>
+        </p:spPr>
+        <p:txBody>
+          <a:bodyPr wrap="square" lIns="114300" tIns="114300" rIns="114300" bIns="114300" rtlCol="0" anchor="ctr"/>
+          <a:lstStyle/>
+          <a:p>
+            <a:pPr indent="0" marL="0">
+              <a:buNone/>
+            </a:pPr>
+            <a:r>
+              <a:rPr lang="en-US" sz="1500" b="1" dirty="0">
+                <a:solidFill>
+                  <a:srgbClr val="B7791F"/>
+                </a:solidFill>
+                <a:latin typeface="Arial" pitchFamily="34" charset="0"/>
+                <a:ea typeface="Arial" pitchFamily="34" charset="-122"/>
+                <a:cs typeface="Arial" pitchFamily="34" charset="-120"/>
+              </a:rPr>
+              <a:t>~765 lines of Python</a:t>
+            </a:r>
+            <a:endParaRPr lang="en-US" sz="1500" dirty="0"/>
+          </a:p>
+          <a:p>
+            <a:pPr indent="0" marL="0">
+              <a:buNone/>
+            </a:pPr>
+            <a:r>
+              <a:rPr lang="en-US" sz="1200" dirty="0">
+                <a:solidFill>
+                  <a:srgbClr val="4A5063"/>
+                </a:solidFill>
+                <a:latin typeface="Arial" pitchFamily="34" charset="0"/>
+                <a:ea typeface="Arial" pitchFamily="34" charset="-122"/>
+                <a:cs typeface="Arial" pitchFamily="34" charset="-120"/>
+              </a:rPr>
+              <a:t>Small enough to read every line</a:t>
+            </a:r>
+            <a:endParaRPr lang="en-US" sz="1500" dirty="0"/>
+          </a:p>
+        </p:txBody>
+      </p:sp>
+      <p:sp>
+        <p:nvSpPr>
+          <p:cNvPr id="9" name="Text 6"/>
+          <p:cNvSpPr txBox="1"/>
+          <p:nvPr/>
+        </p:nvSpPr>
+        <p:spPr>
+          <a:xfrm>
+            <a:off x="5715000" y="2240280"/>
+            <a:ext cx="3017520" cy="822960"/>
+          </a:xfrm>
+          <a:prstGeom prst="rect">
+            <a:avLst/>
+          </a:prstGeom>
+          <a:noFill/>
+          <a:ln/>
+        </p:spPr>
+        <p:txBody>
+          <a:bodyPr wrap="square" lIns="114300" tIns="114300" rIns="114300" bIns="114300" rtlCol="0" anchor="ctr"/>
+          <a:lstStyle/>
+          <a:p>
+            <a:pPr indent="0" marL="0">
+              <a:buNone/>
+            </a:pPr>
+            <a:r>
+              <a:rPr lang="en-US" sz="1500" b="1" dirty="0">
+                <a:solidFill>
+                  <a:srgbClr val="1E9E62"/>
+                </a:solidFill>
+                <a:latin typeface="Arial" pitchFamily="34" charset="0"/>
+                <a:ea typeface="Arial" pitchFamily="34" charset="-122"/>
+                <a:cs typeface="Arial" pitchFamily="34" charset="-120"/>
+              </a:rPr>
+              <a:t>Fully offline</a:t>
+            </a:r>
+            <a:endParaRPr lang="en-US" sz="1500" dirty="0"/>
+          </a:p>
+          <a:p>
+            <a:pPr indent="0" marL="0">
+              <a:buNone/>
+            </a:pPr>
+            <a:r>
+              <a:rPr lang="en-US" sz="1200" dirty="0">
+                <a:solidFill>
+                  <a:srgbClr val="4A5063"/>
+                </a:solidFill>
+                <a:latin typeface="Arial" pitchFamily="34" charset="0"/>
+                <a:ea typeface="Arial" pitchFamily="34" charset="-122"/>
+                <a:cs typeface="Arial" pitchFamily="34" charset="-120"/>
+              </a:rPr>
+              <a:t>Local model, no paid API</a:t>
+            </a:r>
+            <a:endParaRPr lang="en-US" sz="1500" dirty="0"/>
+          </a:p>
+        </p:txBody>
+      </p:sp>
+      <p:sp>
+        <p:nvSpPr>
+          <p:cNvPr id="10" name="Text 7"/>
+          <p:cNvSpPr txBox="1"/>
+          <p:nvPr/>
+        </p:nvSpPr>
+        <p:spPr>
+          <a:xfrm>
+            <a:off x="5715000" y="3177540"/>
+            <a:ext cx="3017520" cy="822960"/>
+          </a:xfrm>
+          <a:prstGeom prst="rect">
+            <a:avLst/>
+          </a:prstGeom>
+          <a:noFill/>
+          <a:ln/>
+        </p:spPr>
+        <p:txBody>
+          <a:bodyPr wrap="square" lIns="114300" tIns="114300" rIns="114300" bIns="114300" rtlCol="0" anchor="ctr"/>
+          <a:lstStyle/>
+          <a:p>
+            <a:pPr indent="0" marL="0">
+              <a:buNone/>
+            </a:pPr>
+            <a:r>
+              <a:rPr lang="en-US" sz="1500" b="1" dirty="0">
+                <a:solidFill>
+                  <a:srgbClr val="2F5FD0"/>
+                </a:solidFill>
+                <a:latin typeface="Arial" pitchFamily="34" charset="0"/>
+                <a:ea typeface="Arial" pitchFamily="34" charset="-122"/>
+                <a:cs typeface="Arial" pitchFamily="34" charset="-120"/>
+              </a:rPr>
+              <a:t>Deterministic</a:t>
+            </a:r>
+            <a:endParaRPr lang="en-US" sz="1500" dirty="0"/>
+          </a:p>
+          <a:p>
+            <a:pPr indent="0" marL="0">
+              <a:buNone/>
+            </a:pPr>
+            <a:r>
+              <a:rPr lang="en-US" sz="1200" dirty="0">
+                <a:solidFill>
+                  <a:srgbClr val="4A5063"/>
+                </a:solidFill>
+                <a:latin typeface="Arial" pitchFamily="34" charset="0"/>
+                <a:ea typeface="Arial" pitchFamily="34" charset="-122"/>
+                <a:cs typeface="Arial" pitchFamily="34" charset="-120"/>
+              </a:rPr>
+              <a:t>Database reset before every test</a:t>
+            </a:r>
+            <a:endParaRPr lang="en-US" sz="1500" dirty="0"/>
+          </a:p>
+        </p:txBody>
+      </p:sp>
+      <p:sp>
+        <p:nvSpPr>
+          <p:cNvPr id="11" name="Text 8"/>
+          <p:cNvSpPr txBox="1"/>
+          <p:nvPr/>
+        </p:nvSpPr>
+        <p:spPr>
+          <a:xfrm>
+            <a:off x="411480" y="4160520"/>
+            <a:ext cx="8321040" cy="457200"/>
+          </a:xfrm>
+          <a:prstGeom prst="rect">
+            <a:avLst/>
+          </a:prstGeom>
+          <a:noFill/>
+          <a:ln/>
+        </p:spPr>
+        <p:txBody>
+          <a:bodyPr wrap="square" lIns="0" tIns="0" rIns="0" bIns="0" rtlCol="0" anchor="ctr"/>
+          <a:lstStyle/>
+          <a:p>
+            <a:pPr algn="ctr" indent="0" marL="0">
+              <a:buNone/>
+            </a:pPr>
+            <a:r>
+              <a:rPr lang="en-US" sz="1275" dirty="0">
                 <a:solidFill>
                   <a:srgbClr val="1C1F26"/>
                 </a:solidFill>
@@ -13696,321 +14067,9 @@
                 <a:ea typeface="Arial" pitchFamily="34" charset="-122"/>
                 <a:cs typeface="Arial" pitchFamily="34" charset="-120"/>
               </a:rPr>
-              <a:t>API:</a:t>
-            </a:r>
-            <a:pPr indent="0" marL="0">
-              <a:spcAft>
-                <a:spcPts val="750"/>
-              </a:spcAft>
-              <a:buNone/>
-            </a:pPr>
-            <a:r>
-              <a:rPr lang="en-US" sz="1425" dirty="0">
-                <a:solidFill>
-                  <a:srgbClr val="4A5063"/>
-                </a:solidFill>
-                <a:latin typeface="Arial" pitchFamily="34" charset="0"/>
-                <a:ea typeface="Arial" pitchFamily="34" charset="-122"/>
-                <a:cs typeface="Arial" pitchFamily="34" charset="-120"/>
-              </a:rPr>
-              <a:t> the way one program asks another for something. Like a waiter between you and the kitchen.</a:t>
-            </a:r>
-            <a:endParaRPr lang="en-US" sz="1425" dirty="0"/>
-          </a:p>
-          <a:p>
-            <a:pPr marL="215900" indent="-215900">
-              <a:spcAft>
-                <a:spcPts val="750"/>
-              </a:spcAft>
-              <a:buSzPct val="100000"/>
-              <a:buChar char="•"/>
-            </a:pPr>
-            <a:r>
-              <a:rPr lang="en-US" sz="1425" b="1" dirty="0">
-                <a:solidFill>
-                  <a:srgbClr val="1C1F26"/>
-                </a:solidFill>
-                <a:latin typeface="Arial" pitchFamily="34" charset="0"/>
-                <a:ea typeface="Arial" pitchFamily="34" charset="-122"/>
-                <a:cs typeface="Arial" pitchFamily="34" charset="-120"/>
-              </a:rPr>
-              <a:t>Request:</a:t>
-            </a:r>
-            <a:pPr indent="0" marL="0">
-              <a:spcAft>
-                <a:spcPts val="750"/>
-              </a:spcAft>
-              <a:buNone/>
-            </a:pPr>
-            <a:r>
-              <a:rPr lang="en-US" sz="1425" dirty="0">
-                <a:solidFill>
-                  <a:srgbClr val="4A5063"/>
-                </a:solidFill>
-                <a:latin typeface="Arial" pitchFamily="34" charset="0"/>
-                <a:ea typeface="Arial" pitchFamily="34" charset="-122"/>
-                <a:cs typeface="Arial" pitchFamily="34" charset="-120"/>
-              </a:rPr>
-              <a:t> a method (GET = read, POST = create), a path, headers (who you are), and a JSON body.</a:t>
-            </a:r>
-            <a:endParaRPr lang="en-US" sz="1425" dirty="0"/>
-          </a:p>
-          <a:p>
-            <a:pPr marL="215900" indent="-215900">
-              <a:spcAft>
-                <a:spcPts val="750"/>
-              </a:spcAft>
-              <a:buSzPct val="100000"/>
-              <a:buChar char="•"/>
-            </a:pPr>
-            <a:r>
-              <a:rPr lang="en-US" sz="1425" b="1" dirty="0">
-                <a:solidFill>
-                  <a:srgbClr val="1C1F26"/>
-                </a:solidFill>
-                <a:latin typeface="Arial" pitchFamily="34" charset="0"/>
-                <a:ea typeface="Arial" pitchFamily="34" charset="-122"/>
-                <a:cs typeface="Arial" pitchFamily="34" charset="-120"/>
-              </a:rPr>
-              <a:t>Response:</a:t>
-            </a:r>
-            <a:pPr indent="0" marL="0">
-              <a:spcAft>
-                <a:spcPts val="750"/>
-              </a:spcAft>
-              <a:buNone/>
-            </a:pPr>
-            <a:r>
-              <a:rPr lang="en-US" sz="1425" dirty="0">
-                <a:solidFill>
-                  <a:srgbClr val="4A5063"/>
-                </a:solidFill>
-                <a:latin typeface="Arial" pitchFamily="34" charset="0"/>
-                <a:ea typeface="Arial" pitchFamily="34" charset="-122"/>
-                <a:cs typeface="Arial" pitchFamily="34" charset="-120"/>
-              </a:rPr>
-              <a:t> a status code plus JSON data.</a:t>
-            </a:r>
-            <a:endParaRPr lang="en-US" sz="1425" dirty="0"/>
-          </a:p>
-        </p:txBody>
-      </p:sp>
-      <p:sp>
-        <p:nvSpPr>
-          <p:cNvPr id="9" name="Text 5"/>
-          <p:cNvSpPr txBox="1"/>
-          <p:nvPr/>
-        </p:nvSpPr>
-        <p:spPr>
-          <a:xfrm>
-            <a:off x="411480" y="2880360"/>
-            <a:ext cx="2640330" cy="1577340"/>
-          </a:xfrm>
-          <a:prstGeom prst="rect">
-            <a:avLst/>
-          </a:prstGeom>
-          <a:noFill/>
-          <a:ln/>
-        </p:spPr>
-        <p:txBody>
-          <a:bodyPr wrap="square" lIns="114300" tIns="114300" rIns="114300" bIns="114300" rtlCol="0" anchor="t"/>
-          <a:lstStyle/>
-          <a:p>
-            <a:pPr indent="0" marL="0">
-              <a:buNone/>
-            </a:pPr>
-            <a:r>
-              <a:rPr lang="en-US" sz="1500" b="1" dirty="0">
-                <a:solidFill>
-                  <a:srgbClr val="1E9E62"/>
-                </a:solidFill>
-                <a:latin typeface="Arial" pitchFamily="34" charset="0"/>
-                <a:ea typeface="Arial" pitchFamily="34" charset="-122"/>
-                <a:cs typeface="Arial" pitchFamily="34" charset="-120"/>
-              </a:rPr>
-              <a:t>2xx  It worked</a:t>
-            </a:r>
-            <a:endParaRPr lang="en-US" sz="1500" dirty="0"/>
-          </a:p>
-          <a:p>
-            <a:pPr indent="0" marL="0">
-              <a:buNone/>
-            </a:pPr>
-            <a:r>
-              <a:rPr lang="en-US" sz="450" dirty="0">
-                <a:solidFill>
-                  <a:srgbClr val="1C1F26"/>
-                </a:solidFill>
-                <a:latin typeface="Arial" pitchFamily="34" charset="0"/>
-                <a:ea typeface="Arial" pitchFamily="34" charset="-122"/>
-                <a:cs typeface="Arial" pitchFamily="34" charset="-120"/>
-              </a:rPr>
-              <a:t> </a:t>
-            </a:r>
-            <a:endParaRPr lang="en-US" sz="1500" dirty="0"/>
-          </a:p>
-          <a:p>
-            <a:pPr indent="0" marL="0">
-              <a:buNone/>
-            </a:pPr>
-            <a:r>
-              <a:rPr lang="en-US" sz="1275" dirty="0">
-                <a:solidFill>
-                  <a:srgbClr val="4A5063"/>
-                </a:solidFill>
-                <a:latin typeface="Arial" pitchFamily="34" charset="0"/>
-                <a:ea typeface="Arial" pitchFamily="34" charset="-122"/>
-                <a:cs typeface="Arial" pitchFamily="34" charset="-120"/>
-              </a:rPr>
-              <a:t>200 OK, 201 Created. Dangerous when it's a lie: "201" for minus five tickets.</a:t>
-            </a:r>
-            <a:endParaRPr lang="en-US" sz="1500" dirty="0"/>
-          </a:p>
-        </p:txBody>
-      </p:sp>
-      <p:sp>
-        <p:nvSpPr>
-          <p:cNvPr id="10" name="Text 6"/>
-          <p:cNvSpPr txBox="1"/>
-          <p:nvPr/>
-        </p:nvSpPr>
-        <p:spPr>
-          <a:xfrm>
-            <a:off x="3250692" y="2880360"/>
-            <a:ext cx="2640330" cy="1577340"/>
-          </a:xfrm>
-          <a:prstGeom prst="rect">
-            <a:avLst/>
-          </a:prstGeom>
-          <a:noFill/>
-          <a:ln/>
-        </p:spPr>
-        <p:txBody>
-          <a:bodyPr wrap="square" lIns="114300" tIns="114300" rIns="114300" bIns="114300" rtlCol="0" anchor="t"/>
-          <a:lstStyle/>
-          <a:p>
-            <a:pPr indent="0" marL="0">
-              <a:buNone/>
-            </a:pPr>
-            <a:r>
-              <a:rPr lang="en-US" sz="1500" b="1" dirty="0">
-                <a:solidFill>
-                  <a:srgbClr val="B7791F"/>
-                </a:solidFill>
-                <a:latin typeface="Arial" pitchFamily="34" charset="0"/>
-                <a:ea typeface="Arial" pitchFamily="34" charset="-122"/>
-                <a:cs typeface="Arial" pitchFamily="34" charset="-120"/>
-              </a:rPr>
-              <a:t>4xx  You asked wrong</a:t>
-            </a:r>
-            <a:endParaRPr lang="en-US" sz="1500" dirty="0"/>
-          </a:p>
-          <a:p>
-            <a:pPr indent="0" marL="0">
-              <a:buNone/>
-            </a:pPr>
-            <a:r>
-              <a:rPr lang="en-US" sz="450" dirty="0">
-                <a:solidFill>
-                  <a:srgbClr val="1C1F26"/>
-                </a:solidFill>
-                <a:latin typeface="Arial" pitchFamily="34" charset="0"/>
-                <a:ea typeface="Arial" pitchFamily="34" charset="-122"/>
-                <a:cs typeface="Arial" pitchFamily="34" charset="-120"/>
-              </a:rPr>
-              <a:t> </a:t>
-            </a:r>
-            <a:endParaRPr lang="en-US" sz="1500" dirty="0"/>
-          </a:p>
-          <a:p>
-            <a:pPr indent="0" marL="0">
-              <a:buNone/>
-            </a:pPr>
-            <a:r>
-              <a:rPr lang="en-US" sz="1275" dirty="0">
-                <a:solidFill>
-                  <a:srgbClr val="4A5063"/>
-                </a:solidFill>
-                <a:latin typeface="Arial" pitchFamily="34" charset="0"/>
-                <a:ea typeface="Arial" pitchFamily="34" charset="-122"/>
-                <a:cs typeface="Arial" pitchFamily="34" charset="-120"/>
-              </a:rPr>
-              <a:t>400, 401, 403, 404. The API refused politely. This is what we want for bad input.</a:t>
-            </a:r>
-            <a:endParaRPr lang="en-US" sz="1500" dirty="0"/>
-          </a:p>
-        </p:txBody>
-      </p:sp>
-      <p:sp>
-        <p:nvSpPr>
-          <p:cNvPr id="11" name="Text 7"/>
-          <p:cNvSpPr txBox="1"/>
-          <p:nvPr/>
-        </p:nvSpPr>
-        <p:spPr>
-          <a:xfrm>
-            <a:off x="6089904" y="2880360"/>
-            <a:ext cx="2640330" cy="1577340"/>
-          </a:xfrm>
-          <a:prstGeom prst="rect">
-            <a:avLst/>
-          </a:prstGeom>
-          <a:noFill/>
-          <a:ln/>
-        </p:spPr>
-        <p:txBody>
-          <a:bodyPr wrap="square" lIns="114300" tIns="114300" rIns="114300" bIns="114300" rtlCol="0" anchor="t"/>
-          <a:lstStyle/>
-          <a:p>
-            <a:pPr indent="0" marL="0">
-              <a:buNone/>
-            </a:pPr>
-            <a:r>
-              <a:rPr lang="en-US" sz="1500" b="1" dirty="0">
-                <a:solidFill>
-                  <a:srgbClr val="D93F3F"/>
-                </a:solidFill>
-                <a:latin typeface="Arial" pitchFamily="34" charset="0"/>
-                <a:ea typeface="Arial" pitchFamily="34" charset="-122"/>
-                <a:cs typeface="Arial" pitchFamily="34" charset="-120"/>
-              </a:rPr>
-              <a:t>5xx  The server broke</a:t>
-            </a:r>
-            <a:endParaRPr lang="en-US" sz="1500" dirty="0"/>
-          </a:p>
-          <a:p>
-            <a:pPr indent="0" marL="0">
-              <a:buNone/>
-            </a:pPr>
-            <a:r>
-              <a:rPr lang="en-US" sz="450" dirty="0">
-                <a:solidFill>
-                  <a:srgbClr val="1C1F26"/>
-                </a:solidFill>
-                <a:latin typeface="Arial" pitchFamily="34" charset="0"/>
-                <a:ea typeface="Arial" pitchFamily="34" charset="-122"/>
-                <a:cs typeface="Arial" pitchFamily="34" charset="-120"/>
-              </a:rPr>
-              <a:t> </a:t>
-            </a:r>
-            <a:endParaRPr lang="en-US" sz="1500" dirty="0"/>
-          </a:p>
-          <a:p>
-            <a:pPr indent="0" marL="0">
-              <a:buNone/>
-            </a:pPr>
-            <a:r>
-              <a:rPr lang="en-US" sz="1275" dirty="0">
-                <a:solidFill>
-                  <a:srgbClr val="4A5063"/>
-                </a:solidFill>
-                <a:latin typeface="Arial" pitchFamily="34" charset="0"/>
-                <a:ea typeface="Arial" pitchFamily="34" charset="-122"/>
-                <a:cs typeface="Arial" pitchFamily="34" charset="-120"/>
-              </a:rPr>
-              <a:t>500. If bad user input causes a 500, that is almost always a bug.</a:t>
-            </a:r>
-            <a:endParaRPr lang="en-US" sz="1500" dirty="0"/>
+              <a:t>Generation (once, ~90 s) and execution (live, ~2 s) share only a JSON file.</a:t>
+            </a:r>
+            <a:endParaRPr lang="en-US" sz="1275" dirty="0"/>
           </a:p>
         </p:txBody>
       </p:sp>

</xml_diff>